<commit_message>
Slides: hook question and concept lines on covers; condense copy to 10 words (sd-06-012..015)
Each cover now carries the lesson's question and one line per main concept,
and the check-question slides and other long lines are cut to at most
10 words, per docs/sd101-slides.md. Badged PPTX files re-exported; the
sd-06-013 cover is now a card grid, recorded in its deck.yaml.

Co-Authored-By: Claude Opus 5.5 <noreply@anthropic.com>
Claude-Session: https://claude.ai/code/session_01C9pH8NnezrynRr5dznPeP3
</commit_message>
<xml_diff>
--- a/system-design-101/vi/lessons/sd-06-012/slides/sd-06-012.pptx
+++ b/system-design-101/vi/lessons/sd-06-012/slides/sd-06-012.pptx
@@ -1880,7 +1880,7 @@
               <a:buNone/>
             </a:pPr>
             <a:r>
-              <a:rPr lang="en-US" sz="3000" dirty="0" spc="11" kern="0">
+              <a:rPr lang="en-US" sz="3000" dirty="0" spc="1" kern="0">
                 <a:solidFill>
                   <a:srgbClr val="E4E1D8"/>
                 </a:solidFill>
@@ -1888,10 +1888,10 @@
                 <a:ea typeface="Be Vietnam Pro" pitchFamily="34" charset="-122"/>
                 <a:cs typeface="Be Vietnam Pro" pitchFamily="34" charset="-120"/>
               </a:rPr>
-              <a:t>Đường</a:t>
-            </a:r>
-            <a:r>
-              <a:rPr lang="en-US" sz="3000" dirty="0" spc="-11" kern="0">
+              <a:t>Ghi cơ</a:t>
+            </a:r>
+            <a:r>
+              <a:rPr lang="en-US" sz="3000" dirty="0" spc="-7" kern="0">
                 <a:solidFill>
                   <a:srgbClr val="E4E1D8"/>
                 </a:solidFill>
@@ -1899,7 +1899,7 @@
                 <a:ea typeface="Be Vietnam Pro" pitchFamily="34" charset="-122"/>
                 <a:cs typeface="Be Vietnam Pro" pitchFamily="34" charset="-120"/>
               </a:rPr>
-              <a:t> găng:</a:t>
+              <a:t> sở</a:t>
             </a:r>
             <a:r>
               <a:rPr lang="en-US" sz="3000" dirty="0" spc="2" kern="0">
@@ -1910,10 +1910,10 @@
                 <a:ea typeface="Be Vietnam Pro" pitchFamily="34" charset="-122"/>
                 <a:cs typeface="Be Vietnam Pro" pitchFamily="34" charset="-120"/>
               </a:rPr>
-              <a:t> chuỗi</a:t>
-            </a:r>
-            <a:r>
-              <a:rPr lang="en-US" sz="3000" dirty="0" spc="0" kern="0">
+              <a:t> dữ liệu</a:t>
+            </a:r>
+            <a:r>
+              <a:rPr lang="en-US" sz="3000" dirty="0" spc="-17" kern="0">
                 <a:solidFill>
                   <a:srgbClr val="E4E1D8"/>
                 </a:solidFill>
@@ -1921,10 +1921,10 @@
                 <a:ea typeface="Be Vietnam Pro" pitchFamily="34" charset="-122"/>
                 <a:cs typeface="Be Vietnam Pro" pitchFamily="34" charset="-120"/>
               </a:rPr>
-              <a:t> việc</a:t>
-            </a:r>
-            <a:r>
-              <a:rPr lang="en-US" sz="3000" dirty="0" spc="1" kern="0">
+              <a:t> xong</a:t>
+            </a:r>
+            <a:r>
+              <a:rPr lang="en-US" sz="3000" dirty="0" spc="4" kern="0">
                 <a:solidFill>
                   <a:srgbClr val="E4E1D8"/>
                 </a:solidFill>
@@ -1932,10 +1932,10 @@
                 <a:ea typeface="Be Vietnam Pro" pitchFamily="34" charset="-122"/>
                 <a:cs typeface="Be Vietnam Pro" pitchFamily="34" charset="-120"/>
               </a:rPr>
-              <a:t> mà</a:t>
-            </a:r>
-            <a:r>
-              <a:rPr lang="en-US" sz="3000" dirty="0" spc="0" kern="0">
+              <a:t> mới</a:t>
+            </a:r>
+            <a:r>
+              <a:rPr lang="en-US" sz="3000" dirty="0" spc="-31" kern="0">
                 <a:solidFill>
                   <a:srgbClr val="E4E1D8"/>
                 </a:solidFill>
@@ -1943,10 +1943,10 @@
                 <a:ea typeface="Be Vietnam Pro" pitchFamily="34" charset="-122"/>
                 <a:cs typeface="Be Vietnam Pro" pitchFamily="34" charset="-120"/>
               </a:rPr>
-              <a:t> lệnh</a:t>
-            </a:r>
-            <a:r>
-              <a:rPr lang="en-US" sz="3000" dirty="0" spc="-19" kern="0">
+              <a:t> trả</a:t>
+            </a:r>
+            <a:r>
+              <a:rPr lang="en-US" sz="3000" dirty="0" spc="-40" kern="0">
                 <a:solidFill>
                   <a:srgbClr val="E4E1D8"/>
                 </a:solidFill>
@@ -1954,10 +1954,10 @@
                 <a:ea typeface="Be Vietnam Pro" pitchFamily="34" charset="-122"/>
                 <a:cs typeface="Be Vietnam Pro" pitchFamily="34" charset="-120"/>
               </a:rPr>
-              <a:t> bắt</a:t>
-            </a:r>
-            <a:r>
-              <a:rPr lang="en-US" sz="3000" dirty="0" spc="0" kern="0">
+              <a:t> kết</a:t>
+            </a:r>
+            <a:r>
+              <a:rPr lang="en-US" sz="3000" dirty="0" spc="-1" kern="0">
                 <a:solidFill>
                   <a:srgbClr val="E4E1D8"/>
                 </a:solidFill>
@@ -1965,40 +1965,7 @@
                 <a:ea typeface="Be Vietnam Pro" pitchFamily="34" charset="-122"/>
                 <a:cs typeface="Be Vietnam Pro" pitchFamily="34" charset="-120"/>
               </a:rPr>
-              <a:t> buộc</a:t>
-            </a:r>
-            <a:r>
-              <a:rPr lang="en-US" sz="3000" dirty="0" spc="2" kern="0">
-                <a:solidFill>
-                  <a:srgbClr val="E4E1D8"/>
-                </a:solidFill>
-                <a:latin typeface="Be Vietnam Pro" pitchFamily="34" charset="0"/>
-                <a:ea typeface="Be Vietnam Pro" pitchFamily="34" charset="-122"/>
-                <a:cs typeface="Be Vietnam Pro" pitchFamily="34" charset="-120"/>
-              </a:rPr>
-              <a:t> phải</a:t>
-            </a:r>
-            <a:r>
-              <a:rPr lang="en-US" sz="3000" dirty="0" spc="41" kern="0">
-                <a:solidFill>
-                  <a:srgbClr val="E4E1D8"/>
-                </a:solidFill>
-                <a:latin typeface="Be Vietnam Pro" pitchFamily="34" charset="0"/>
-                <a:ea typeface="Be Vietnam Pro" pitchFamily="34" charset="-122"/>
-                <a:cs typeface="Be Vietnam Pro" pitchFamily="34" charset="-120"/>
-              </a:rPr>
-              <a:t> đi</a:t>
-            </a:r>
-            <a:r>
-              <a:rPr lang="en-US" sz="3000" dirty="0" spc="1" kern="0">
-                <a:solidFill>
-                  <a:srgbClr val="E4E1D8"/>
-                </a:solidFill>
-                <a:latin typeface="Be Vietnam Pro" pitchFamily="34" charset="0"/>
-                <a:ea typeface="Be Vietnam Pro" pitchFamily="34" charset="-122"/>
-                <a:cs typeface="Be Vietnam Pro" pitchFamily="34" charset="-120"/>
-              </a:rPr>
-              <a:t> qua.</a:t>
+              <a:t> quả?</a:t>
             </a:r>
             <a:endParaRPr lang="en-US" sz="3000" dirty="0"/>
           </a:p>
@@ -2013,7 +1980,7 @@
         <p:spPr>
           <a:xfrm>
             <a:off x="914400" y="6381750"/>
-            <a:ext cx="3810000" cy="1905000"/>
+            <a:ext cx="4953000" cy="1905000"/>
           </a:xfrm>
           <a:prstGeom prst="roundRect">
             <a:avLst>
@@ -2040,7 +2007,7 @@
         <p:spPr>
           <a:xfrm>
             <a:off x="1181100" y="6381750"/>
-            <a:ext cx="3276600" cy="1905000"/>
+            <a:ext cx="4419600" cy="1905000"/>
           </a:xfrm>
           <a:prstGeom prst="rect">
             <a:avLst/>
@@ -2056,26 +2023,26 @@
               <a:buNone/>
             </a:pPr>
             <a:r>
-              <a:rPr lang="en-US" sz="3300" dirty="0" spc="4" kern="0">
-                <a:solidFill>
-                  <a:srgbClr val="F3EEE3"/>
+              <a:rPr lang="en-US" sz="3300" dirty="0" spc="-39" kern="0">
+                <a:solidFill>
+                  <a:srgbClr val="7C93FF"/>
                 </a:solidFill>
                 <a:latin typeface="Bricolage Grotesque ExtraBold" pitchFamily="34" charset="0"/>
                 <a:ea typeface="Bricolage Grotesque ExtraBold" pitchFamily="34" charset="-122"/>
                 <a:cs typeface="Bricolage Grotesque ExtraBold" pitchFamily="34" charset="-120"/>
               </a:rPr>
-              <a:t>Nhận</a:t>
-            </a:r>
-            <a:r>
-              <a:rPr lang="en-US" sz="3300" dirty="0" spc="1" kern="0">
-                <a:solidFill>
-                  <a:srgbClr val="F3EEE3"/>
+              <a:t>Đường</a:t>
+            </a:r>
+            <a:r>
+              <a:rPr lang="en-US" sz="3300" dirty="0" spc="-6" kern="0">
+                <a:solidFill>
+                  <a:srgbClr val="7C93FF"/>
                 </a:solidFill>
                 <a:latin typeface="Bricolage Grotesque ExtraBold" pitchFamily="34" charset="0"/>
                 <a:ea typeface="Bricolage Grotesque ExtraBold" pitchFamily="34" charset="-122"/>
                 <a:cs typeface="Bricolage Grotesque ExtraBold" pitchFamily="34" charset="-120"/>
               </a:rPr>
-              <a:t> lệnh</a:t>
+              <a:t> găng</a:t>
             </a:r>
             <a:endParaRPr lang="en-US" sz="3300" dirty="0"/>
           </a:p>
@@ -2083,14 +2050,14 @@
       </p:sp>
       <p:sp>
         <p:nvSpPr>
-          <p:cNvPr id="7" name="Connector line-1792372065761-415984678"/>
-          <p:cNvSpPr/>
-          <p:nvPr/>
-        </p:nvSpPr>
-        <p:spPr>
-          <a:xfrm>
-            <a:off x="4762500" y="7334250"/>
-            <a:ext cx="342900" cy="0"/>
+          <p:cNvPr id="7" name="Connector line-1792373055488-988764099"/>
+          <p:cNvSpPr/>
+          <p:nvPr/>
+        </p:nvSpPr>
+        <p:spPr>
+          <a:xfrm>
+            <a:off x="5924550" y="7334250"/>
+            <a:ext cx="571500" cy="0"/>
           </a:xfrm>
           <a:prstGeom prst="line">
             <a:avLst/>
@@ -2098,7 +2065,7 @@
           <a:noFill/>
           <a:ln w="38100">
             <a:solidFill>
-              <a:srgbClr val="7C93FF"/>
+              <a:srgbClr val="9AA0B5"/>
             </a:solidFill>
             <a:prstDash val="solid"/>
             <a:headEnd type="none"/>
@@ -2114,8 +2081,8 @@
         </p:nvSpPr>
         <p:spPr>
           <a:xfrm>
-            <a:off x="5143500" y="6381750"/>
-            <a:ext cx="3810000" cy="1905000"/>
+            <a:off x="6553200" y="6381750"/>
+            <a:ext cx="4953000" cy="1905000"/>
           </a:xfrm>
           <a:prstGeom prst="roundRect">
             <a:avLst>
@@ -2127,7 +2094,7 @@
           </a:solidFill>
           <a:ln w="28575">
             <a:solidFill>
-              <a:srgbClr val="7C93FF"/>
+              <a:srgbClr val="FFB454"/>
             </a:solidFill>
             <a:prstDash val="solid"/>
           </a:ln>
@@ -2141,8 +2108,8 @@
         </p:nvSpPr>
         <p:spPr>
           <a:xfrm>
-            <a:off x="5410200" y="6381750"/>
-            <a:ext cx="3276600" cy="1905000"/>
+            <a:off x="6819900" y="6381750"/>
+            <a:ext cx="4419600" cy="1905000"/>
           </a:xfrm>
           <a:prstGeom prst="rect">
             <a:avLst/>
@@ -2158,48 +2125,59 @@
               <a:buNone/>
             </a:pPr>
             <a:r>
-              <a:rPr lang="en-US" sz="3300" dirty="0" spc="2" kern="0">
-                <a:solidFill>
-                  <a:srgbClr val="F3EEE3"/>
+              <a:rPr lang="en-US" sz="3300" dirty="0" spc="-2" kern="0">
+                <a:solidFill>
+                  <a:srgbClr val="FFB454"/>
                 </a:solidFill>
                 <a:latin typeface="Bricolage Grotesque ExtraBold" pitchFamily="34" charset="0"/>
                 <a:ea typeface="Bricolage Grotesque ExtraBold" pitchFamily="34" charset="-122"/>
                 <a:cs typeface="Bricolage Grotesque ExtraBold" pitchFamily="34" charset="-120"/>
               </a:rPr>
-              <a:t>Kiểm</a:t>
-            </a:r>
-            <a:r>
-              <a:rPr lang="en-US" sz="3300" dirty="0" spc="-15" kern="0">
-                <a:solidFill>
-                  <a:srgbClr val="F3EEE3"/>
+              <a:t>Bốn</a:t>
+            </a:r>
+            <a:r>
+              <a:rPr lang="en-US" sz="3300" dirty="0" spc="3" kern="0">
+                <a:solidFill>
+                  <a:srgbClr val="FFB454"/>
                 </a:solidFill>
                 <a:latin typeface="Bricolage Grotesque ExtraBold" pitchFamily="34" charset="0"/>
                 <a:ea typeface="Bricolage Grotesque ExtraBold" pitchFamily="34" charset="-122"/>
                 <a:cs typeface="Bricolage Grotesque ExtraBold" pitchFamily="34" charset="-120"/>
               </a:rPr>
-              <a:t> tra</a:t>
-            </a:r>
-            <a:r>
-              <a:rPr lang="en-US" sz="3300" dirty="0" spc="1" kern="0">
-                <a:solidFill>
-                  <a:srgbClr val="F3EEE3"/>
+              <a:t> cách</a:t>
+            </a:r>
+            <a:r>
+              <a:rPr lang="en-US" sz="3300" dirty="0" spc="-1" kern="0">
+                <a:solidFill>
+                  <a:srgbClr val="FFB454"/>
                 </a:solidFill>
                 <a:latin typeface="Bricolage Grotesque ExtraBold" pitchFamily="34" charset="0"/>
                 <a:ea typeface="Bricolage Grotesque ExtraBold" pitchFamily="34" charset="-122"/>
                 <a:cs typeface="Bricolage Grotesque ExtraBold" pitchFamily="34" charset="-120"/>
               </a:rPr>
-              <a:t> rủi</a:t>
-            </a:r>
-            <a:r>
-              <a:rPr lang="en-US" sz="3300" dirty="0" spc="-18" kern="0">
-                <a:solidFill>
-                  <a:srgbClr val="F3EEE3"/>
+              <a:t> làm</a:t>
+            </a:r>
+            <a:r>
+              <a:rPr lang="en-US" sz="3300" dirty="0" spc="-2" kern="0">
+                <a:solidFill>
+                  <a:srgbClr val="FFB454"/>
                 </a:solidFill>
                 <a:latin typeface="Bricolage Grotesque ExtraBold" pitchFamily="34" charset="0"/>
                 <a:ea typeface="Bricolage Grotesque ExtraBold" pitchFamily="34" charset="-122"/>
                 <a:cs typeface="Bricolage Grotesque ExtraBold" pitchFamily="34" charset="-120"/>
               </a:rPr>
-              <a:t> ro</a:t>
+              <a:t> ít</a:t>
+            </a:r>
+            <a:r>
+              <a:rPr lang="en-US" sz="3300" dirty="0" spc="-19" kern="0">
+                <a:solidFill>
+                  <a:srgbClr val="FFB454"/>
+                </a:solidFill>
+                <a:latin typeface="Bricolage Grotesque ExtraBold" pitchFamily="34" charset="0"/>
+                <a:ea typeface="Bricolage Grotesque ExtraBold" pitchFamily="34" charset="-122"/>
+                <a:cs typeface="Bricolage Grotesque ExtraBold" pitchFamily="34" charset="-120"/>
+              </a:rPr>
+              <a:t> hơn</a:t>
             </a:r>
             <a:endParaRPr lang="en-US" sz="3300" dirty="0"/>
           </a:p>
@@ -2207,14 +2185,14 @@
       </p:sp>
       <p:sp>
         <p:nvSpPr>
-          <p:cNvPr id="10" name="Connector line-1792372065764-765880174"/>
-          <p:cNvSpPr/>
-          <p:nvPr/>
-        </p:nvSpPr>
-        <p:spPr>
-          <a:xfrm>
-            <a:off x="8991600" y="7334250"/>
-            <a:ext cx="342900" cy="0"/>
+          <p:cNvPr id="10" name="Connector line-1792373055492-353965714"/>
+          <p:cNvSpPr/>
+          <p:nvPr/>
+        </p:nvSpPr>
+        <p:spPr>
+          <a:xfrm>
+            <a:off x="11563350" y="7334250"/>
+            <a:ext cx="571500" cy="0"/>
           </a:xfrm>
           <a:prstGeom prst="line">
             <a:avLst/>
@@ -2222,7 +2200,7 @@
           <a:noFill/>
           <a:ln w="38100">
             <a:solidFill>
-              <a:srgbClr val="7C93FF"/>
+              <a:srgbClr val="9AA0B5"/>
             </a:solidFill>
             <a:prstDash val="solid"/>
             <a:headEnd type="none"/>
@@ -2238,8 +2216,8 @@
         </p:nvSpPr>
         <p:spPr>
           <a:xfrm>
-            <a:off x="9372600" y="6381750"/>
-            <a:ext cx="3810000" cy="1905000"/>
+            <a:off x="12192000" y="6381750"/>
+            <a:ext cx="4953000" cy="1905000"/>
           </a:xfrm>
           <a:prstGeom prst="roundRect">
             <a:avLst>
@@ -2247,11 +2225,11 @@
             </a:avLst>
           </a:prstGeom>
           <a:solidFill>
-            <a:srgbClr val="7C93FF"/>
+            <a:srgbClr val="1E212B"/>
           </a:solidFill>
           <a:ln w="28575">
             <a:solidFill>
-              <a:srgbClr val="7C93FF"/>
+              <a:srgbClr val="3DD6A0"/>
             </a:solidFill>
             <a:prstDash val="solid"/>
           </a:ln>
@@ -2265,8 +2243,8 @@
         </p:nvSpPr>
         <p:spPr>
           <a:xfrm>
-            <a:off x="9639300" y="6381750"/>
-            <a:ext cx="3276600" cy="1905000"/>
+            <a:off x="12458700" y="6381750"/>
+            <a:ext cx="4419600" cy="1905000"/>
           </a:xfrm>
           <a:prstGeom prst="rect">
             <a:avLst/>
@@ -2282,26 +2260,48 @@
               <a:buNone/>
             </a:pPr>
             <a:r>
-              <a:rPr lang="en-US" sz="3300" dirty="0" spc="-19" kern="0">
-                <a:solidFill>
-                  <a:srgbClr val="14161C"/>
+              <a:rPr lang="en-US" sz="3300" dirty="0" spc="-4" kern="0">
+                <a:solidFill>
+                  <a:srgbClr val="3DD6A0"/>
                 </a:solidFill>
                 <a:latin typeface="Bricolage Grotesque ExtraBold" pitchFamily="34" charset="0"/>
                 <a:ea typeface="Bricolage Grotesque ExtraBold" pitchFamily="34" charset="-122"/>
                 <a:cs typeface="Bricolage Grotesque ExtraBold" pitchFamily="34" charset="-120"/>
               </a:rPr>
-              <a:t>Khớp</a:t>
-            </a:r>
-            <a:r>
-              <a:rPr lang="en-US" sz="3300" dirty="0" spc="1" kern="0">
-                <a:solidFill>
-                  <a:srgbClr val="14161C"/>
+              <a:t>Vì</a:t>
+            </a:r>
+            <a:r>
+              <a:rPr lang="en-US" sz="3300" dirty="0" spc="0" kern="0">
+                <a:solidFill>
+                  <a:srgbClr val="3DD6A0"/>
                 </a:solidFill>
                 <a:latin typeface="Bricolage Grotesque ExtraBold" pitchFamily="34" charset="0"/>
                 <a:ea typeface="Bricolage Grotesque ExtraBold" pitchFamily="34" charset="-122"/>
                 <a:cs typeface="Bricolage Grotesque ExtraBold" pitchFamily="34" charset="-120"/>
               </a:rPr>
-              <a:t> lệnh</a:t>
+              <a:t> sao</a:t>
+            </a:r>
+            <a:r>
+              <a:rPr lang="en-US" sz="3300" dirty="0" spc="-3" kern="0">
+                <a:solidFill>
+                  <a:srgbClr val="3DD6A0"/>
+                </a:solidFill>
+                <a:latin typeface="Bricolage Grotesque ExtraBold" pitchFamily="34" charset="0"/>
+                <a:ea typeface="Bricolage Grotesque ExtraBold" pitchFamily="34" charset="-122"/>
+                <a:cs typeface="Bricolage Grotesque ExtraBold" pitchFamily="34" charset="-120"/>
+              </a:rPr>
+              <a:t> khóa</a:t>
+            </a:r>
+            <a:r>
+              <a:rPr lang="en-US" sz="3300" dirty="0" spc="5" kern="0">
+                <a:solidFill>
+                  <a:srgbClr val="3DD6A0"/>
+                </a:solidFill>
+                <a:latin typeface="Bricolage Grotesque ExtraBold" pitchFamily="34" charset="0"/>
+                <a:ea typeface="Bricolage Grotesque ExtraBold" pitchFamily="34" charset="-122"/>
+                <a:cs typeface="Bricolage Grotesque ExtraBold" pitchFamily="34" charset="-120"/>
+              </a:rPr>
+              <a:t> đắt</a:t>
             </a:r>
             <a:endParaRPr lang="en-US" sz="3300" dirty="0"/>
           </a:p>
@@ -2309,120 +2309,7 @@
       </p:sp>
       <p:sp>
         <p:nvSpPr>
-          <p:cNvPr id="13" name="Connector line-1792372065767-487036508"/>
-          <p:cNvSpPr/>
-          <p:nvPr/>
-        </p:nvSpPr>
-        <p:spPr>
-          <a:xfrm>
-            <a:off x="13220700" y="7334250"/>
-            <a:ext cx="342900" cy="0"/>
-          </a:xfrm>
-          <a:prstGeom prst="line">
-            <a:avLst/>
-          </a:prstGeom>
-          <a:noFill/>
-          <a:ln w="38100">
-            <a:solidFill>
-              <a:srgbClr val="7C93FF"/>
-            </a:solidFill>
-            <a:prstDash val="solid"/>
-            <a:headEnd type="none"/>
-            <a:tailEnd type="triangle" w="lg" len="lg"/>
-          </a:ln>
-        </p:spPr>
-      </p:sp>
-      <p:sp>
-        <p:nvSpPr>
-          <p:cNvPr id="14" name="Shape 12"/>
-          <p:cNvSpPr/>
-          <p:nvPr/>
-        </p:nvSpPr>
-        <p:spPr>
-          <a:xfrm>
-            <a:off x="13601700" y="6381750"/>
-            <a:ext cx="3810000" cy="1905000"/>
-          </a:xfrm>
-          <a:prstGeom prst="roundRect">
-            <a:avLst>
-              <a:gd name="adj" fmla="val 12000"/>
-            </a:avLst>
-          </a:prstGeom>
-          <a:solidFill>
-            <a:srgbClr val="1E212B"/>
-          </a:solidFill>
-          <a:ln w="28575">
-            <a:solidFill>
-              <a:srgbClr val="7C93FF"/>
-            </a:solidFill>
-            <a:prstDash val="solid"/>
-          </a:ln>
-        </p:spPr>
-      </p:sp>
-      <p:sp>
-        <p:nvSpPr>
-          <p:cNvPr id="15" name="Text 13"/>
-          <p:cNvSpPr/>
-          <p:nvPr/>
-        </p:nvSpPr>
-        <p:spPr>
-          <a:xfrm>
-            <a:off x="13868400" y="6381750"/>
-            <a:ext cx="3276600" cy="1905000"/>
-          </a:xfrm>
-          <a:prstGeom prst="rect">
-            <a:avLst/>
-          </a:prstGeom>
-          <a:noFill/>
-          <a:ln/>
-        </p:spPr>
-        <p:txBody>
-          <a:bodyPr wrap="square" lIns="0" tIns="0" rIns="0" bIns="0" rtlCol="0" anchor="ctr"/>
-          <a:lstStyle/>
-          <a:p>
-            <a:pPr algn="ctr" indent="0" marL="0">
-              <a:buNone/>
-            </a:pPr>
-            <a:r>
-              <a:rPr lang="en-US" sz="3300" dirty="0" spc="24" kern="0">
-                <a:solidFill>
-                  <a:srgbClr val="F3EEE3"/>
-                </a:solidFill>
-                <a:latin typeface="Bricolage Grotesque ExtraBold" pitchFamily="34" charset="0"/>
-                <a:ea typeface="Bricolage Grotesque ExtraBold" pitchFamily="34" charset="-122"/>
-                <a:cs typeface="Bricolage Grotesque ExtraBold" pitchFamily="34" charset="-120"/>
-              </a:rPr>
-              <a:t>Gửi</a:t>
-            </a:r>
-            <a:r>
-              <a:rPr lang="en-US" sz="3300" dirty="0" spc="-21" kern="0">
-                <a:solidFill>
-                  <a:srgbClr val="F3EEE3"/>
-                </a:solidFill>
-                <a:latin typeface="Bricolage Grotesque ExtraBold" pitchFamily="34" charset="0"/>
-                <a:ea typeface="Bricolage Grotesque ExtraBold" pitchFamily="34" charset="-122"/>
-                <a:cs typeface="Bricolage Grotesque ExtraBold" pitchFamily="34" charset="-120"/>
-              </a:rPr>
-              <a:t> kết</a:t>
-            </a:r>
-            <a:r>
-              <a:rPr lang="en-US" sz="3300" dirty="0" spc="-2" kern="0">
-                <a:solidFill>
-                  <a:srgbClr val="F3EEE3"/>
-                </a:solidFill>
-                <a:latin typeface="Bricolage Grotesque ExtraBold" pitchFamily="34" charset="0"/>
-                <a:ea typeface="Bricolage Grotesque ExtraBold" pitchFamily="34" charset="-122"/>
-                <a:cs typeface="Bricolage Grotesque ExtraBold" pitchFamily="34" charset="-120"/>
-              </a:rPr>
-              <a:t> quả</a:t>
-            </a:r>
-            <a:endParaRPr lang="en-US" sz="3300" dirty="0"/>
-          </a:p>
-        </p:txBody>
-      </p:sp>
-      <p:sp>
-        <p:nvSpPr>
-          <p:cNvPr id="16" name="Text 14"/>
+          <p:cNvPr id="13" name="Text 11"/>
           <p:cNvSpPr/>
           <p:nvPr/>
         </p:nvSpPr>
@@ -2593,7 +2480,7 @@
       </p:sp>
       <p:sp>
         <p:nvSpPr>
-          <p:cNvPr id="17" name="Shape 15"/>
+          <p:cNvPr id="14" name="Shape 12"/>
           <p:cNvSpPr/>
           <p:nvPr/>
         </p:nvSpPr>
@@ -2617,7 +2504,7 @@
       </p:sp>
       <p:pic>
         <p:nvPicPr>
-          <p:cNvPr id="18" name="Moda image moda-export-watermark-5fbccd65-b154-47d8-9a18-ca3352addcf7" descr="">    </p:cNvPr>
+          <p:cNvPr id="15" name="Moda image moda-export-watermark-5fbccd65-b154-47d8-9a18-ca3352addcf7" descr="">    </p:cNvPr>
           <p:cNvPicPr>
             <a:picLocks noChangeAspect="1"/>
           </p:cNvPicPr>
@@ -2972,7 +2859,7 @@
               <a:t> khi</a:t>
             </a:r>
             <a:r>
-              <a:rPr lang="en-US" sz="2400" dirty="0" spc="1" kern="0">
+              <a:rPr lang="en-US" sz="2400" dirty="0" spc="0" kern="0">
                 <a:solidFill>
                   <a:srgbClr val="14161C"/>
                 </a:solidFill>
@@ -2980,10 +2867,10 @@
                 <a:ea typeface="Be Vietnam Pro" pitchFamily="34" charset="-122"/>
                 <a:cs typeface="Be Vietnam Pro" pitchFamily="34" charset="-120"/>
               </a:rPr>
-              <a:t> luồng nhận</a:t>
-            </a:r>
-            <a:r>
-              <a:rPr lang="en-US" sz="2400" dirty="0" spc="3" kern="0">
+              <a:t> chờ</a:t>
+            </a:r>
+            <a:r>
+              <a:rPr lang="en-US" sz="2400" dirty="0" spc="-1" kern="0">
                 <a:solidFill>
                   <a:srgbClr val="14161C"/>
                 </a:solidFill>
@@ -2991,18 +2878,7 @@
                 <a:ea typeface="Be Vietnam Pro" pitchFamily="34" charset="-122"/>
                 <a:cs typeface="Be Vietnam Pro" pitchFamily="34" charset="-120"/>
               </a:rPr>
-              <a:t> ngủ</a:t>
-            </a:r>
-            <a:r>
-              <a:rPr lang="en-US" sz="2400" dirty="0" spc="0" kern="0">
-                <a:solidFill>
-                  <a:srgbClr val="14161C"/>
-                </a:solidFill>
-                <a:latin typeface="Be Vietnam Pro" pitchFamily="34" charset="0"/>
-                <a:ea typeface="Be Vietnam Pro" pitchFamily="34" charset="-122"/>
-                <a:cs typeface="Be Vietnam Pro" pitchFamily="34" charset="-120"/>
-              </a:rPr>
-              <a:t> chờ hệ</a:t>
+              <a:t> hệ</a:t>
             </a:r>
             <a:r>
               <a:rPr lang="en-US" sz="2400" dirty="0" spc="18" kern="0">
@@ -3699,50 +3575,6 @@
             </a:r>
             <a:r>
               <a:rPr lang="en-US" sz="1950" dirty="0" spc="0" kern="0">
-                <a:solidFill>
-                  <a:srgbClr val="6B6A66"/>
-                </a:solidFill>
-                <a:latin typeface="Be Vietnam Pro" pitchFamily="34" charset="0"/>
-                <a:ea typeface="Be Vietnam Pro" pitchFamily="34" charset="-122"/>
-                <a:cs typeface="Be Vietnam Pro" pitchFamily="34" charset="-120"/>
-              </a:rPr>
-              <a:t> hai</a:t>
-            </a:r>
-            <a:r>
-              <a:rPr lang="en-US" sz="1950" dirty="0" spc="1" kern="0">
-                <a:solidFill>
-                  <a:srgbClr val="6B6A66"/>
-                </a:solidFill>
-                <a:latin typeface="Be Vietnam Pro" pitchFamily="34" charset="0"/>
-                <a:ea typeface="Be Vietnam Pro" pitchFamily="34" charset="-122"/>
-                <a:cs typeface="Be Vietnam Pro" pitchFamily="34" charset="-120"/>
-              </a:rPr>
-              <a:t> luồng</a:t>
-            </a:r>
-            <a:r>
-              <a:rPr lang="en-US" sz="1950" dirty="0" spc="2" kern="0">
-                <a:solidFill>
-                  <a:srgbClr val="6B6A66"/>
-                </a:solidFill>
-                <a:latin typeface="Be Vietnam Pro" pitchFamily="34" charset="0"/>
-                <a:ea typeface="Be Vietnam Pro" pitchFamily="34" charset="-122"/>
-                <a:cs typeface="Be Vietnam Pro" pitchFamily="34" charset="-120"/>
-              </a:rPr>
-              <a:t> ghim</a:t>
-            </a:r>
-            <a:r>
-              <a:rPr lang="en-US" sz="1950" dirty="0" spc="-11" kern="0">
-                <a:solidFill>
-                  <a:srgbClr val="6B6A66"/>
-                </a:solidFill>
-                <a:latin typeface="Be Vietnam Pro" pitchFamily="34" charset="0"/>
-                <a:ea typeface="Be Vietnam Pro" pitchFamily="34" charset="-122"/>
-                <a:cs typeface="Be Vietnam Pro" pitchFamily="34" charset="-120"/>
-              </a:rPr>
-              <a:t> vào</a:t>
-            </a:r>
-            <a:r>
-              <a:rPr lang="en-US" sz="1950" dirty="0" spc="1" kern="0">
                 <a:solidFill>
                   <a:srgbClr val="6B6A66"/>
                 </a:solidFill>
@@ -6437,7 +6269,7 @@
               <a:t> một</a:t>
             </a:r>
             <a:r>
-              <a:rPr lang="en-US" sz="2250" dirty="0" spc="-10" kern="0">
+              <a:rPr lang="en-US" sz="2250" dirty="0" spc="-9" kern="0">
                 <a:solidFill>
                   <a:srgbClr val="E4E1D8"/>
                 </a:solidFill>
@@ -6445,18 +6277,7 @@
                 <a:ea typeface="Be Vietnam Pro" pitchFamily="34" charset="-122"/>
                 <a:cs typeface="Be Vietnam Pro" pitchFamily="34" charset="-120"/>
               </a:rPr>
-              <a:t> máy</a:t>
-            </a:r>
-            <a:r>
-              <a:rPr lang="en-US" sz="2250" dirty="0" spc="1" kern="0">
-                <a:solidFill>
-                  <a:srgbClr val="E4E1D8"/>
-                </a:solidFill>
-                <a:latin typeface="Be Vietnam Pro" pitchFamily="34" charset="0"/>
-                <a:ea typeface="Be Vietnam Pro" pitchFamily="34" charset="-122"/>
-                <a:cs typeface="Be Vietnam Pro" pitchFamily="34" charset="-120"/>
-              </a:rPr>
-              <a:t> lớn,</a:t>
+              <a:t> máy,</a:t>
             </a:r>
             <a:r>
               <a:rPr lang="en-US" sz="2250" dirty="0" spc="-20" kern="0">
@@ -6774,7 +6595,7 @@
               <a:buNone/>
             </a:pPr>
             <a:r>
-              <a:rPr lang="en-US" sz="2400" b="1" dirty="0" spc="-9" kern="0">
+              <a:rPr lang="en-US" sz="2400" b="1" dirty="0" spc="-11" kern="0">
                 <a:solidFill>
                   <a:srgbClr val="14161C"/>
                 </a:solidFill>
@@ -6782,10 +6603,10 @@
                 <a:ea typeface="Be Vietnam Pro" pitchFamily="34" charset="-122"/>
                 <a:cs typeface="Be Vietnam Pro" pitchFamily="34" charset="-120"/>
               </a:rPr>
-              <a:t>Một</a:t>
-            </a:r>
-            <a:r>
-              <a:rPr lang="en-US" sz="2400" b="1" dirty="0" spc="-5" kern="0">
+              <a:t>Luồng</a:t>
+            </a:r>
+            <a:r>
+              <a:rPr lang="en-US" sz="2400" b="1" dirty="0" spc="-1" kern="0">
                 <a:solidFill>
                   <a:srgbClr val="14161C"/>
                 </a:solidFill>
@@ -6793,10 +6614,10 @@
                 <a:ea typeface="Be Vietnam Pro" pitchFamily="34" charset="-122"/>
                 <a:cs typeface="Be Vietnam Pro" pitchFamily="34" charset="-120"/>
               </a:rPr>
-              <a:t> luồng</a:t>
-            </a:r>
-            <a:r>
-              <a:rPr lang="en-US" sz="2400" b="1" dirty="0" spc="0" kern="0">
+              <a:t> riêng</a:t>
+            </a:r>
+            <a:r>
+              <a:rPr lang="en-US" sz="2400" b="1" dirty="0" spc="-11" kern="0">
                 <a:solidFill>
                   <a:srgbClr val="14161C"/>
                 </a:solidFill>
@@ -6804,10 +6625,10 @@
                 <a:ea typeface="Be Vietnam Pro" pitchFamily="34" charset="-122"/>
                 <a:cs typeface="Be Vietnam Pro" pitchFamily="34" charset="-120"/>
               </a:rPr>
-              <a:t> sở</a:t>
-            </a:r>
-            <a:r>
-              <a:rPr lang="en-US" sz="2400" b="1" dirty="0" spc="33" kern="0">
+              <a:t> hết</a:t>
+            </a:r>
+            <a:r>
+              <a:rPr lang="en-US" sz="2400" b="1" dirty="0" spc="-6" kern="0">
                 <a:solidFill>
                   <a:srgbClr val="14161C"/>
                 </a:solidFill>
@@ -6815,10 +6636,10 @@
                 <a:ea typeface="Be Vietnam Pro" pitchFamily="34" charset="-122"/>
                 <a:cs typeface="Be Vietnam Pro" pitchFamily="34" charset="-120"/>
               </a:rPr>
-              <a:t> hữu</a:t>
-            </a:r>
-            <a:r>
-              <a:rPr lang="en-US" sz="2400" b="1" dirty="0" spc="3" kern="0">
+              <a:t> tranh</a:t>
+            </a:r>
+            <a:r>
+              <a:rPr lang="en-US" sz="2400" b="1" dirty="0" spc="-3" kern="0">
                 <a:solidFill>
                   <a:srgbClr val="14161C"/>
                 </a:solidFill>
@@ -6826,10 +6647,10 @@
                 <a:ea typeface="Be Vietnam Pro" pitchFamily="34" charset="-122"/>
                 <a:cs typeface="Be Vietnam Pro" pitchFamily="34" charset="-120"/>
               </a:rPr>
-              <a:t> dữ</a:t>
-            </a:r>
-            <a:r>
-              <a:rPr lang="en-US" sz="2400" b="1" dirty="0" spc="0" kern="0">
+              <a:t> khóa;</a:t>
+            </a:r>
+            <a:r>
+              <a:rPr lang="en-US" sz="2400" b="1" dirty="0" spc="-1" kern="0">
                 <a:solidFill>
                   <a:srgbClr val="14161C"/>
                 </a:solidFill>
@@ -6837,7 +6658,7 @@
                 <a:ea typeface="Be Vietnam Pro" pitchFamily="34" charset="-122"/>
                 <a:cs typeface="Be Vietnam Pro" pitchFamily="34" charset="-120"/>
               </a:rPr>
-              <a:t> liệu:</a:t>
+              <a:t> ghim</a:t>
             </a:r>
             <a:r>
               <a:rPr lang="en-US" sz="2400" b="1" dirty="0" spc="-2" kern="0">
@@ -6848,10 +6669,32 @@
                 <a:ea typeface="Be Vietnam Pro" pitchFamily="34" charset="-122"/>
                 <a:cs typeface="Be Vietnam Pro" pitchFamily="34" charset="-120"/>
               </a:rPr>
+              <a:t> lõi</a:t>
+            </a:r>
+            <a:r>
+              <a:rPr lang="en-US" sz="2400" b="1" dirty="0" spc="-1" kern="0">
+                <a:solidFill>
+                  <a:srgbClr val="14161C"/>
+                </a:solidFill>
+                <a:latin typeface="Be Vietnam Pro" pitchFamily="34" charset="0"/>
+                <a:ea typeface="Be Vietnam Pro" pitchFamily="34" charset="-122"/>
+                <a:cs typeface="Be Vietnam Pro" pitchFamily="34" charset="-120"/>
+              </a:rPr>
+              <a:t> chỉ</a:t>
+            </a:r>
+            <a:r>
+              <a:rPr lang="en-US" sz="2400" b="1" dirty="0" spc="-3" kern="0">
+                <a:solidFill>
+                  <a:srgbClr val="14161C"/>
+                </a:solidFill>
+                <a:latin typeface="Be Vietnam Pro" pitchFamily="34" charset="0"/>
+                <a:ea typeface="Be Vietnam Pro" pitchFamily="34" charset="-122"/>
+                <a:cs typeface="Be Vietnam Pro" pitchFamily="34" charset="-120"/>
+              </a:rPr>
               <a:t> khỏi</a:t>
             </a:r>
             <a:r>
-              <a:rPr lang="en-US" sz="2400" b="1" dirty="0" spc="-7" kern="0">
+              <a:rPr lang="en-US" sz="2400" b="1" dirty="0" spc="-13" kern="0">
                 <a:solidFill>
                   <a:srgbClr val="14161C"/>
                 </a:solidFill>
@@ -6859,106 +6702,7 @@
                 <a:ea typeface="Be Vietnam Pro" pitchFamily="34" charset="-122"/>
                 <a:cs typeface="Be Vietnam Pro" pitchFamily="34" charset="-120"/>
               </a:rPr>
-              <a:t> tranh</a:t>
-            </a:r>
-            <a:r>
-              <a:rPr lang="en-US" sz="2400" b="1" dirty="0" spc="-2" kern="0">
-                <a:solidFill>
-                  <a:srgbClr val="14161C"/>
-                </a:solidFill>
-                <a:latin typeface="Be Vietnam Pro" pitchFamily="34" charset="0"/>
-                <a:ea typeface="Be Vietnam Pro" pitchFamily="34" charset="-122"/>
-                <a:cs typeface="Be Vietnam Pro" pitchFamily="34" charset="-120"/>
-              </a:rPr>
-              <a:t> khóa. Ghim</a:t>
-            </a:r>
-            <a:r>
-              <a:rPr lang="en-US" sz="2400" b="1" dirty="0" spc="-9" kern="0">
-                <a:solidFill>
-                  <a:srgbClr val="14161C"/>
-                </a:solidFill>
-                <a:latin typeface="Be Vietnam Pro" pitchFamily="34" charset="0"/>
-                <a:ea typeface="Be Vietnam Pro" pitchFamily="34" charset="-122"/>
-                <a:cs typeface="Be Vietnam Pro" pitchFamily="34" charset="-120"/>
-              </a:rPr>
-              <a:t> vào</a:t>
-            </a:r>
-            <a:r>
-              <a:rPr lang="en-US" sz="2400" b="1" dirty="0" spc="-8" kern="0">
-                <a:solidFill>
-                  <a:srgbClr val="14161C"/>
-                </a:solidFill>
-                <a:latin typeface="Be Vietnam Pro" pitchFamily="34" charset="0"/>
-                <a:ea typeface="Be Vietnam Pro" pitchFamily="34" charset="-122"/>
-                <a:cs typeface="Be Vietnam Pro" pitchFamily="34" charset="-120"/>
-              </a:rPr>
-              <a:t> một</a:t>
-            </a:r>
-            <a:r>
-              <a:rPr lang="en-US" sz="2400" b="1" dirty="0" spc="0" kern="0">
-                <a:solidFill>
-                  <a:srgbClr val="14161C"/>
-                </a:solidFill>
-                <a:latin typeface="Be Vietnam Pro" pitchFamily="34" charset="0"/>
-                <a:ea typeface="Be Vietnam Pro" pitchFamily="34" charset="-122"/>
-                <a:cs typeface="Be Vietnam Pro" pitchFamily="34" charset="-120"/>
-              </a:rPr>
-              <a:t> lõi:</a:t>
-            </a:r>
-            <a:r>
-              <a:rPr lang="en-US" sz="2400" b="1" dirty="0" spc="-1" kern="0">
-                <a:solidFill>
-                  <a:srgbClr val="14161C"/>
-                </a:solidFill>
-                <a:latin typeface="Be Vietnam Pro" pitchFamily="34" charset="0"/>
-                <a:ea typeface="Be Vietnam Pro" pitchFamily="34" charset="-122"/>
-                <a:cs typeface="Be Vietnam Pro" pitchFamily="34" charset="-120"/>
-              </a:rPr>
-              <a:t> chỉ</a:t>
-            </a:r>
-            <a:r>
-              <a:rPr lang="en-US" sz="2400" b="1" dirty="0" spc="-3" kern="0">
-                <a:solidFill>
-                  <a:srgbClr val="14161C"/>
-                </a:solidFill>
-                <a:latin typeface="Be Vietnam Pro" pitchFamily="34" charset="0"/>
-                <a:ea typeface="Be Vietnam Pro" pitchFamily="34" charset="-122"/>
-                <a:cs typeface="Be Vietnam Pro" pitchFamily="34" charset="-120"/>
-              </a:rPr>
-              <a:t> khỏi</a:t>
-            </a:r>
-            <a:r>
-              <a:rPr lang="en-US" sz="2400" b="1" dirty="0" spc="2" kern="0">
-                <a:solidFill>
-                  <a:srgbClr val="14161C"/>
-                </a:solidFill>
-                <a:latin typeface="Be Vietnam Pro" pitchFamily="34" charset="0"/>
-                <a:ea typeface="Be Vietnam Pro" pitchFamily="34" charset="-122"/>
-                <a:cs typeface="Be Vietnam Pro" pitchFamily="34" charset="-120"/>
-              </a:rPr>
-              <a:t> bị</a:t>
-            </a:r>
-            <a:r>
-              <a:rPr lang="en-US" sz="2400" b="1" dirty="0" spc="-16" kern="0">
-                <a:solidFill>
-                  <a:srgbClr val="14161C"/>
-                </a:solidFill>
-                <a:latin typeface="Be Vietnam Pro" pitchFamily="34" charset="0"/>
-                <a:ea typeface="Be Vietnam Pro" pitchFamily="34" charset="-122"/>
-                <a:cs typeface="Be Vietnam Pro" pitchFamily="34" charset="-120"/>
-              </a:rPr>
-              <a:t> chuyển</a:t>
-            </a:r>
-            <a:r>
-              <a:rPr lang="en-US" sz="2400" b="1" dirty="0" spc="0" kern="0">
-                <a:solidFill>
-                  <a:srgbClr val="14161C"/>
-                </a:solidFill>
-                <a:latin typeface="Be Vietnam Pro" pitchFamily="34" charset="0"/>
-                <a:ea typeface="Be Vietnam Pro" pitchFamily="34" charset="-122"/>
-                <a:cs typeface="Be Vietnam Pro" pitchFamily="34" charset="-120"/>
-              </a:rPr>
-              <a:t> lõi.</a:t>
+              <a:t> chuyển.</a:t>
             </a:r>
             <a:endParaRPr lang="en-US" sz="2400" dirty="0"/>
           </a:p>
@@ -8571,6 +8315,28 @@
               <a:t> hành</a:t>
             </a:r>
             <a:r>
+              <a:rPr lang="en-US" sz="2400" b="1" dirty="0" spc="-1" kern="0">
+                <a:solidFill>
+                  <a:srgbClr val="0F766E"/>
+                </a:solidFill>
+                <a:latin typeface="Be Vietnam Pro" pitchFamily="34" charset="0"/>
+                <a:ea typeface="Be Vietnam Pro" pitchFamily="34" charset="-122"/>
+                <a:cs typeface="Be Vietnam Pro" pitchFamily="34" charset="-120"/>
+              </a:rPr>
+              <a:t> tạm</a:t>
+            </a:r>
+            <a:r>
+              <a:rPr lang="en-US" sz="2400" b="1" dirty="0" spc="22" kern="0">
+                <a:solidFill>
+                  <a:srgbClr val="0F766E"/>
+                </a:solidFill>
+                <a:latin typeface="Be Vietnam Pro" pitchFamily="34" charset="0"/>
+                <a:ea typeface="Be Vietnam Pro" pitchFamily="34" charset="-122"/>
+                <a:cs typeface="Be Vietnam Pro" pitchFamily="34" charset="-120"/>
+              </a:rPr>
+              <a:t> dừng</a:t>
+            </a:r>
+            <a:r>
               <a:rPr lang="en-US" sz="2400" b="1" dirty="0" spc="-4" kern="0">
                 <a:solidFill>
                   <a:srgbClr val="0F766E"/>
@@ -8579,54 +8345,10 @@
                 <a:ea typeface="Be Vietnam Pro" pitchFamily="34" charset="-122"/>
                 <a:cs typeface="Be Vietnam Pro" pitchFamily="34" charset="-120"/>
               </a:rPr>
-              <a:t> phân</a:t>
-            </a:r>
-            <a:r>
-              <a:rPr lang="en-US" sz="2400" b="1" dirty="0" spc="3" kern="0">
-                <a:solidFill>
-                  <a:srgbClr val="0F766E"/>
-                </a:solidFill>
-                <a:latin typeface="Be Vietnam Pro" pitchFamily="34" charset="0"/>
-                <a:ea typeface="Be Vietnam Pro" pitchFamily="34" charset="-122"/>
-                <a:cs typeface="Be Vietnam Pro" pitchFamily="34" charset="-120"/>
-              </a:rPr>
-              <a:t> xử,</a:t>
-            </a:r>
-            <a:r>
-              <a:rPr lang="en-US" sz="2400" b="1" dirty="0" spc="-1" kern="0">
-                <a:solidFill>
-                  <a:srgbClr val="0F766E"/>
-                </a:solidFill>
-                <a:latin typeface="Be Vietnam Pro" pitchFamily="34" charset="0"/>
-                <a:ea typeface="Be Vietnam Pro" pitchFamily="34" charset="-122"/>
-                <a:cs typeface="Be Vietnam Pro" pitchFamily="34" charset="-120"/>
-              </a:rPr>
-              <a:t> tạm</a:t>
-            </a:r>
-            <a:r>
-              <a:rPr lang="en-US" sz="2400" b="1" dirty="0" spc="22" kern="0">
-                <a:solidFill>
-                  <a:srgbClr val="0F766E"/>
-                </a:solidFill>
-                <a:latin typeface="Be Vietnam Pro" pitchFamily="34" charset="0"/>
-                <a:ea typeface="Be Vietnam Pro" pitchFamily="34" charset="-122"/>
-                <a:cs typeface="Be Vietnam Pro" pitchFamily="34" charset="-120"/>
-              </a:rPr>
-              <a:t> dừng</a:t>
-            </a:r>
-            <a:r>
-              <a:rPr lang="en-US" sz="2400" b="1" dirty="0" spc="-5" kern="0">
-                <a:solidFill>
-                  <a:srgbClr val="0F766E"/>
-                </a:solidFill>
-                <a:latin typeface="Be Vietnam Pro" pitchFamily="34" charset="0"/>
-                <a:ea typeface="Be Vietnam Pro" pitchFamily="34" charset="-122"/>
-                <a:cs typeface="Be Vietnam Pro" pitchFamily="34" charset="-120"/>
-              </a:rPr>
               <a:t> luồng</a:t>
             </a:r>
             <a:r>
-              <a:rPr lang="en-US" sz="2400" b="1" dirty="0" spc="3" kern="0">
+              <a:rPr lang="en-US" sz="2400" b="1" dirty="0" spc="2" kern="0">
                 <a:solidFill>
                   <a:srgbClr val="0F766E"/>
                 </a:solidFill>
@@ -10792,7 +10514,7 @@
               <a:buNone/>
             </a:pPr>
             <a:r>
-              <a:rPr lang="en-US" sz="2850" dirty="0" spc="-4" kern="0">
+              <a:rPr lang="en-US" sz="2850" dirty="0" spc="-3" kern="0">
                 <a:solidFill>
                   <a:srgbClr val="F3EEE3"/>
                 </a:solidFill>
@@ -10800,7 +10522,40 @@
                 <a:ea typeface="Be Vietnam Pro" pitchFamily="34" charset="-122"/>
                 <a:cs typeface="Be Vietnam Pro" pitchFamily="34" charset="-120"/>
               </a:rPr>
-              <a:t>Đồng</a:t>
+              <a:t>Chờ</a:t>
+            </a:r>
+            <a:r>
+              <a:rPr lang="en-US" sz="2850" dirty="0" spc="1" kern="0">
+                <a:solidFill>
+                  <a:srgbClr val="F3EEE3"/>
+                </a:solidFill>
+                <a:latin typeface="Be Vietnam Pro" pitchFamily="34" charset="0"/>
+                <a:ea typeface="Be Vietnam Pro" pitchFamily="34" charset="-122"/>
+                <a:cs typeface="Be Vietnam Pro" pitchFamily="34" charset="-120"/>
+              </a:rPr>
+              <a:t> ghi</a:t>
+            </a:r>
+            <a:r>
+              <a:rPr lang="en-US" sz="2850" dirty="0" spc="2" kern="0">
+                <a:solidFill>
+                  <a:srgbClr val="F3EEE3"/>
+                </a:solidFill>
+                <a:latin typeface="Be Vietnam Pro" pitchFamily="34" charset="0"/>
+                <a:ea typeface="Be Vietnam Pro" pitchFamily="34" charset="-122"/>
+                <a:cs typeface="Be Vietnam Pro" pitchFamily="34" charset="-120"/>
+              </a:rPr>
+              <a:t> cơ</a:t>
+            </a:r>
+            <a:r>
+              <a:rPr lang="en-US" sz="2850" dirty="0" spc="-10" kern="0">
+                <a:solidFill>
+                  <a:srgbClr val="F3EEE3"/>
+                </a:solidFill>
+                <a:latin typeface="Be Vietnam Pro" pitchFamily="34" charset="0"/>
+                <a:ea typeface="Be Vietnam Pro" pitchFamily="34" charset="-122"/>
+                <a:cs typeface="Be Vietnam Pro" pitchFamily="34" charset="-120"/>
+              </a:rPr>
+              <a:t> sở</a:t>
             </a:r>
             <a:r>
               <a:rPr lang="en-US" sz="2850" dirty="0" spc="-1" kern="0">
@@ -10811,10 +10566,10 @@
                 <a:ea typeface="Be Vietnam Pro" pitchFamily="34" charset="-122"/>
                 <a:cs typeface="Be Vietnam Pro" pitchFamily="34" charset="-120"/>
               </a:rPr>
-              <a:t> nghiệp</a:t>
-            </a:r>
-            <a:r>
-              <a:rPr lang="en-US" sz="2850" dirty="0" spc="-2" kern="0">
+              <a:t> dữ</a:t>
+            </a:r>
+            <a:r>
+              <a:rPr lang="en-US" sz="2850" dirty="0" spc="2" kern="0">
                 <a:solidFill>
                   <a:srgbClr val="F3EEE3"/>
                 </a:solidFill>
@@ -10822,10 +10577,10 @@
                 <a:ea typeface="Be Vietnam Pro" pitchFamily="34" charset="-122"/>
                 <a:cs typeface="Be Vietnam Pro" pitchFamily="34" charset="-120"/>
               </a:rPr>
-              <a:t> muốn</a:t>
-            </a:r>
-            <a:r>
-              <a:rPr lang="en-US" sz="2850" dirty="0" spc="0" kern="0">
+              <a:t> liệu</a:t>
+            </a:r>
+            <a:r>
+              <a:rPr lang="en-US" sz="2850" dirty="0" spc="-1" kern="0">
                 <a:solidFill>
                   <a:srgbClr val="F3EEE3"/>
                 </a:solidFill>
@@ -10833,10 +10588,10 @@
                 <a:ea typeface="Be Vietnam Pro" pitchFamily="34" charset="-122"/>
                 <a:cs typeface="Be Vietnam Pro" pitchFamily="34" charset="-120"/>
               </a:rPr>
-              <a:t> ghi mỗi lệnh</a:t>
-            </a:r>
-            <a:r>
-              <a:rPr lang="en-US" sz="2850" dirty="0" spc="-2" kern="0">
+              <a:t> mới</a:t>
+            </a:r>
+            <a:r>
+              <a:rPr lang="en-US" sz="2850" dirty="0" spc="-21" kern="0">
                 <a:solidFill>
                   <a:srgbClr val="F3EEE3"/>
                 </a:solidFill>
@@ -10844,10 +10599,10 @@
                 <a:ea typeface="Be Vietnam Pro" pitchFamily="34" charset="-122"/>
                 <a:cs typeface="Be Vietnam Pro" pitchFamily="34" charset="-120"/>
               </a:rPr>
-              <a:t> khớp</a:t>
-            </a:r>
-            <a:r>
-              <a:rPr lang="en-US" sz="2850" dirty="0" spc="0" kern="0">
+              <a:t> trả:</a:t>
+            </a:r>
+            <a:r>
+              <a:rPr lang="en-US" sz="2850" dirty="0" spc="-8" kern="0">
                 <a:solidFill>
                   <a:srgbClr val="F3EEE3"/>
                 </a:solidFill>
@@ -10855,10 +10610,10 @@
                 <a:ea typeface="Be Vietnam Pro" pitchFamily="34" charset="-122"/>
                 <a:cs typeface="Be Vietnam Pro" pitchFamily="34" charset="-120"/>
               </a:rPr>
-              <a:t> xuống</a:t>
-            </a:r>
-            <a:r>
-              <a:rPr lang="en-US" sz="2850" dirty="0" spc="2" kern="0">
+              <a:t> thay</a:t>
+            </a:r>
+            <a:r>
+              <a:rPr lang="en-US" sz="2850" dirty="0" spc="-1" kern="0">
                 <a:solidFill>
                   <a:srgbClr val="F3EEE3"/>
                 </a:solidFill>
@@ -10866,161 +10621,7 @@
                 <a:ea typeface="Be Vietnam Pro" pitchFamily="34" charset="-122"/>
                 <a:cs typeface="Be Vietnam Pro" pitchFamily="34" charset="-120"/>
               </a:rPr>
-              <a:t> cơ</a:t>
-            </a:r>
-            <a:r>
-              <a:rPr lang="en-US" sz="2850" dirty="0" spc="-10" kern="0">
-                <a:solidFill>
-                  <a:srgbClr val="F3EEE3"/>
-                </a:solidFill>
-                <a:latin typeface="Be Vietnam Pro" pitchFamily="34" charset="0"/>
-                <a:ea typeface="Be Vietnam Pro" pitchFamily="34" charset="-122"/>
-                <a:cs typeface="Be Vietnam Pro" pitchFamily="34" charset="-120"/>
-              </a:rPr>
-              <a:t> sở</a:t>
-            </a:r>
-            <a:r>
-              <a:rPr lang="en-US" sz="2850" dirty="0" spc="-1" kern="0">
-                <a:solidFill>
-                  <a:srgbClr val="F3EEE3"/>
-                </a:solidFill>
-                <a:latin typeface="Be Vietnam Pro" pitchFamily="34" charset="0"/>
-                <a:ea typeface="Be Vietnam Pro" pitchFamily="34" charset="-122"/>
-                <a:cs typeface="Be Vietnam Pro" pitchFamily="34" charset="-120"/>
-              </a:rPr>
-              <a:t> dữ</a:t>
-            </a:r>
-            <a:r>
-              <a:rPr lang="en-US" sz="2850" dirty="0" spc="2" kern="0">
-                <a:solidFill>
-                  <a:srgbClr val="F3EEE3"/>
-                </a:solidFill>
-                <a:latin typeface="Be Vietnam Pro" pitchFamily="34" charset="0"/>
-                <a:ea typeface="Be Vietnam Pro" pitchFamily="34" charset="-122"/>
-                <a:cs typeface="Be Vietnam Pro" pitchFamily="34" charset="-120"/>
-              </a:rPr>
-              <a:t> liệu,</a:t>
-            </a:r>
-            <a:r>
-              <a:rPr lang="en-US" sz="2850" dirty="0" spc="-1" kern="0">
-                <a:solidFill>
-                  <a:srgbClr val="F3EEE3"/>
-                </a:solidFill>
-                <a:latin typeface="Be Vietnam Pro" pitchFamily="34" charset="0"/>
-                <a:ea typeface="Be Vietnam Pro" pitchFamily="34" charset="-122"/>
-                <a:cs typeface="Be Vietnam Pro" pitchFamily="34" charset="-120"/>
-              </a:rPr>
-              <a:t> chờ</a:t>
-            </a:r>
-            <a:r>
-              <a:rPr lang="en-US" sz="2850" dirty="0" spc="-16" kern="0">
-                <a:solidFill>
-                  <a:srgbClr val="F3EEE3"/>
-                </a:solidFill>
-                <a:latin typeface="Be Vietnam Pro" pitchFamily="34" charset="0"/>
-                <a:ea typeface="Be Vietnam Pro" pitchFamily="34" charset="-122"/>
-                <a:cs typeface="Be Vietnam Pro" pitchFamily="34" charset="-120"/>
-              </a:rPr>
-              <a:t> xong</a:t>
-            </a:r>
-            <a:r>
-              <a:rPr lang="en-US" sz="2850" dirty="0" spc="-26" kern="0">
-                <a:solidFill>
-                  <a:srgbClr val="F3EEE3"/>
-                </a:solidFill>
-                <a:latin typeface="Be Vietnam Pro" pitchFamily="34" charset="0"/>
-                <a:ea typeface="Be Vietnam Pro" pitchFamily="34" charset="-122"/>
-                <a:cs typeface="Be Vietnam Pro" pitchFamily="34" charset="-120"/>
-              </a:rPr>
-              <a:t> rồi</a:t>
-            </a:r>
-            <a:r>
-              <a:rPr lang="en-US" sz="2850" dirty="0" spc="-1" kern="0">
-                <a:solidFill>
-                  <a:srgbClr val="F3EEE3"/>
-                </a:solidFill>
-                <a:latin typeface="Be Vietnam Pro" pitchFamily="34" charset="0"/>
-                <a:ea typeface="Be Vietnam Pro" pitchFamily="34" charset="-122"/>
-                <a:cs typeface="Be Vietnam Pro" pitchFamily="34" charset="-120"/>
-              </a:rPr>
-              <a:t> mới</a:t>
-            </a:r>
-            <a:r>
-              <a:rPr lang="en-US" sz="2850" dirty="0" spc="-27" kern="0">
-                <a:solidFill>
-                  <a:srgbClr val="F3EEE3"/>
-                </a:solidFill>
-                <a:latin typeface="Be Vietnam Pro" pitchFamily="34" charset="0"/>
-                <a:ea typeface="Be Vietnam Pro" pitchFamily="34" charset="-122"/>
-                <a:cs typeface="Be Vietnam Pro" pitchFamily="34" charset="-120"/>
-              </a:rPr>
-              <a:t> trả</a:t>
-            </a:r>
-            <a:r>
-              <a:rPr lang="en-US" sz="2850" dirty="0" spc="-41" kern="0">
-                <a:solidFill>
-                  <a:srgbClr val="F3EEE3"/>
-                </a:solidFill>
-                <a:latin typeface="Be Vietnam Pro" pitchFamily="34" charset="0"/>
-                <a:ea typeface="Be Vietnam Pro" pitchFamily="34" charset="-122"/>
-                <a:cs typeface="Be Vietnam Pro" pitchFamily="34" charset="-120"/>
-              </a:rPr>
-              <a:t> kết</a:t>
-            </a:r>
-            <a:r>
-              <a:rPr lang="en-US" sz="2850" dirty="0" spc="0" kern="0">
-                <a:solidFill>
-                  <a:srgbClr val="F3EEE3"/>
-                </a:solidFill>
-                <a:latin typeface="Be Vietnam Pro" pitchFamily="34" charset="0"/>
-                <a:ea typeface="Be Vietnam Pro" pitchFamily="34" charset="-122"/>
-                <a:cs typeface="Be Vietnam Pro" pitchFamily="34" charset="-120"/>
-              </a:rPr>
-              <a:t> quả.</a:t>
-            </a:r>
-            <a:r>
-              <a:rPr lang="en-US" sz="2850" dirty="0" spc="-27" kern="0">
-                <a:solidFill>
-                  <a:srgbClr val="F3EEE3"/>
-                </a:solidFill>
-                <a:latin typeface="Be Vietnam Pro" pitchFamily="34" charset="0"/>
-                <a:ea typeface="Be Vietnam Pro" pitchFamily="34" charset="-122"/>
-                <a:cs typeface="Be Vietnam Pro" pitchFamily="34" charset="-120"/>
-              </a:rPr>
-              <a:t> Làm</a:t>
-            </a:r>
-            <a:r>
-              <a:rPr lang="en-US" sz="2850" dirty="0" spc="-1" kern="0">
-                <a:solidFill>
-                  <a:srgbClr val="F3EEE3"/>
-                </a:solidFill>
-                <a:latin typeface="Be Vietnam Pro" pitchFamily="34" charset="0"/>
-                <a:ea typeface="Be Vietnam Pro" pitchFamily="34" charset="-122"/>
-                <a:cs typeface="Be Vietnam Pro" pitchFamily="34" charset="-120"/>
-              </a:rPr>
-              <a:t> gì</a:t>
-            </a:r>
-            <a:r>
-              <a:rPr lang="en-US" sz="2850" dirty="0" spc="-8" kern="0">
-                <a:solidFill>
-                  <a:srgbClr val="F3EEE3"/>
-                </a:solidFill>
-                <a:latin typeface="Be Vietnam Pro" pitchFamily="34" charset="0"/>
-                <a:ea typeface="Be Vietnam Pro" pitchFamily="34" charset="-122"/>
-                <a:cs typeface="Be Vietnam Pro" pitchFamily="34" charset="-120"/>
-              </a:rPr>
-              <a:t> thay</a:t>
-            </a:r>
-            <a:r>
-              <a:rPr lang="en-US" sz="2850" dirty="0" spc="-1" kern="0">
-                <a:solidFill>
-                  <a:srgbClr val="F3EEE3"/>
-                </a:solidFill>
-                <a:latin typeface="Be Vietnam Pro" pitchFamily="34" charset="0"/>
-                <a:ea typeface="Be Vietnam Pro" pitchFamily="34" charset="-122"/>
-                <a:cs typeface="Be Vietnam Pro" pitchFamily="34" charset="-120"/>
-              </a:rPr>
-              <a:t> thế?</a:t>
+              <a:t> gì?</a:t>
             </a:r>
             <a:endParaRPr lang="en-US" sz="2850" dirty="0"/>
           </a:p>
@@ -11794,6 +11395,17 @@
               <a:buNone/>
             </a:pPr>
             <a:r>
+              <a:rPr lang="en-US" sz="2400" dirty="0" spc="-36" kern="0">
+                <a:solidFill>
+                  <a:srgbClr val="E4E1D8"/>
+                </a:solidFill>
+                <a:latin typeface="Be Vietnam Pro" pitchFamily="34" charset="0"/>
+                <a:ea typeface="Be Vietnam Pro" pitchFamily="34" charset="-122"/>
+                <a:cs typeface="Be Vietnam Pro" pitchFamily="34" charset="-120"/>
+              </a:rPr>
+              <a:t>Vẫn</a:t>
+            </a:r>
+            <a:r>
               <a:rPr lang="en-US" sz="2400" dirty="0" spc="1" kern="0">
                 <a:solidFill>
                   <a:srgbClr val="E4E1D8"/>
@@ -11802,7 +11414,73 @@
                 <a:ea typeface="Be Vietnam Pro" pitchFamily="34" charset="-122"/>
                 <a:cs typeface="Be Vietnam Pro" pitchFamily="34" charset="-120"/>
               </a:rPr>
-              <a:t>Cần</a:t>
+              <a:t> cần</a:t>
+            </a:r>
+            <a:r>
+              <a:rPr lang="en-US" sz="2400" dirty="0" spc="-8" kern="0">
+                <a:solidFill>
+                  <a:srgbClr val="E4E1D8"/>
+                </a:solidFill>
+                <a:latin typeface="Be Vietnam Pro" pitchFamily="34" charset="0"/>
+                <a:ea typeface="Be Vietnam Pro" pitchFamily="34" charset="-122"/>
+                <a:cs typeface="Be Vietnam Pro" pitchFamily="34" charset="-120"/>
+              </a:rPr>
+              <a:t> nhật</a:t>
+            </a:r>
+            <a:r>
+              <a:rPr lang="en-US" sz="2400" dirty="0" spc="-2" kern="0">
+                <a:solidFill>
+                  <a:srgbClr val="E4E1D8"/>
+                </a:solidFill>
+                <a:latin typeface="Be Vietnam Pro" pitchFamily="34" charset="0"/>
+                <a:ea typeface="Be Vietnam Pro" pitchFamily="34" charset="-122"/>
+                <a:cs typeface="Be Vietnam Pro" pitchFamily="34" charset="-120"/>
+              </a:rPr>
+              <a:t> ký</a:t>
+            </a:r>
+            <a:r>
+              <a:rPr lang="en-US" sz="2400" dirty="0" spc="-1" kern="0">
+                <a:solidFill>
+                  <a:srgbClr val="E4E1D8"/>
+                </a:solidFill>
+                <a:latin typeface="Be Vietnam Pro" pitchFamily="34" charset="0"/>
+                <a:ea typeface="Be Vietnam Pro" pitchFamily="34" charset="-122"/>
+                <a:cs typeface="Be Vietnam Pro" pitchFamily="34" charset="-120"/>
+              </a:rPr>
+              <a:t> hoặc bản</a:t>
+            </a:r>
+            <a:r>
+              <a:rPr lang="en-US" sz="2400" dirty="0" spc="-5" kern="0">
+                <a:solidFill>
+                  <a:srgbClr val="E4E1D8"/>
+                </a:solidFill>
+                <a:latin typeface="Be Vietnam Pro" pitchFamily="34" charset="0"/>
+                <a:ea typeface="Be Vietnam Pro" pitchFamily="34" charset="-122"/>
+                <a:cs typeface="Be Vietnam Pro" pitchFamily="34" charset="-120"/>
+              </a:rPr>
+              <a:t> sao</a:t>
+            </a:r>
+            <a:r>
+              <a:rPr lang="en-US" sz="2400" dirty="0" spc="1" kern="0">
+                <a:solidFill>
+                  <a:srgbClr val="E4E1D8"/>
+                </a:solidFill>
+                <a:latin typeface="Be Vietnam Pro" pitchFamily="34" charset="0"/>
+                <a:ea typeface="Be Vietnam Pro" pitchFamily="34" charset="-122"/>
+                <a:cs typeface="Be Vietnam Pro" pitchFamily="34" charset="-120"/>
+              </a:rPr>
+              <a:t> chống</a:t>
+            </a:r>
+            <a:r>
+              <a:rPr lang="en-US" sz="2400" dirty="0" spc="-9" kern="0">
+                <a:solidFill>
+                  <a:srgbClr val="E4E1D8"/>
+                </a:solidFill>
+                <a:latin typeface="Be Vietnam Pro" pitchFamily="34" charset="0"/>
+                <a:ea typeface="Be Vietnam Pro" pitchFamily="34" charset="-122"/>
+                <a:cs typeface="Be Vietnam Pro" pitchFamily="34" charset="-120"/>
+              </a:rPr>
+              <a:t> mất</a:t>
             </a:r>
             <a:r>
               <a:rPr lang="en-US" sz="2400" dirty="0" spc="0" kern="0">
@@ -11813,227 +11491,7 @@
                 <a:ea typeface="Be Vietnam Pro" pitchFamily="34" charset="-122"/>
                 <a:cs typeface="Be Vietnam Pro" pitchFamily="34" charset="-120"/>
               </a:rPr>
-              <a:t> cách</a:t>
-            </a:r>
-            <a:r>
-              <a:rPr lang="en-US" sz="2400" dirty="0" spc="-1" kern="0">
-                <a:solidFill>
-                  <a:srgbClr val="E4E1D8"/>
-                </a:solidFill>
-                <a:latin typeface="Be Vietnam Pro" pitchFamily="34" charset="0"/>
-                <a:ea typeface="Be Vietnam Pro" pitchFamily="34" charset="-122"/>
-                <a:cs typeface="Be Vietnam Pro" pitchFamily="34" charset="-120"/>
-              </a:rPr>
-              <a:t> khác</a:t>
-            </a:r>
-            <a:r>
-              <a:rPr lang="en-US" sz="2400" dirty="0" spc="17" kern="0">
-                <a:solidFill>
-                  <a:srgbClr val="E4E1D8"/>
-                </a:solidFill>
-                <a:latin typeface="Be Vietnam Pro" pitchFamily="34" charset="0"/>
-                <a:ea typeface="Be Vietnam Pro" pitchFamily="34" charset="-122"/>
-                <a:cs typeface="Be Vietnam Pro" pitchFamily="34" charset="-120"/>
-              </a:rPr>
-              <a:t> để</a:t>
-            </a:r>
-            <a:r>
-              <a:rPr lang="en-US" sz="2400" dirty="0" spc="0" kern="0">
-                <a:solidFill>
-                  <a:srgbClr val="E4E1D8"/>
-                </a:solidFill>
-                <a:latin typeface="Be Vietnam Pro" pitchFamily="34" charset="0"/>
-                <a:ea typeface="Be Vietnam Pro" pitchFamily="34" charset="-122"/>
-                <a:cs typeface="Be Vietnam Pro" pitchFamily="34" charset="-120"/>
-              </a:rPr>
-              <a:t> không</a:t>
-            </a:r>
-            <a:r>
-              <a:rPr lang="en-US" sz="2400" dirty="0" spc="-8" kern="0">
-                <a:solidFill>
-                  <a:srgbClr val="E4E1D8"/>
-                </a:solidFill>
-                <a:latin typeface="Be Vietnam Pro" pitchFamily="34" charset="0"/>
-                <a:ea typeface="Be Vietnam Pro" pitchFamily="34" charset="-122"/>
-                <a:cs typeface="Be Vietnam Pro" pitchFamily="34" charset="-120"/>
-              </a:rPr>
-              <a:t> mất</a:t>
-            </a:r>
-            <a:r>
-              <a:rPr lang="en-US" sz="2400" dirty="0" spc="0" kern="0">
-                <a:solidFill>
-                  <a:srgbClr val="E4E1D8"/>
-                </a:solidFill>
-                <a:latin typeface="Be Vietnam Pro" pitchFamily="34" charset="0"/>
-                <a:ea typeface="Be Vietnam Pro" pitchFamily="34" charset="-122"/>
-                <a:cs typeface="Be Vietnam Pro" pitchFamily="34" charset="-120"/>
-              </a:rPr>
-              <a:t> lệnh</a:t>
-            </a:r>
-            <a:r>
-              <a:rPr lang="en-US" sz="2400" dirty="0" spc="-2" kern="0">
-                <a:solidFill>
-                  <a:srgbClr val="E4E1D8"/>
-                </a:solidFill>
-                <a:latin typeface="Be Vietnam Pro" pitchFamily="34" charset="0"/>
-                <a:ea typeface="Be Vietnam Pro" pitchFamily="34" charset="-122"/>
-                <a:cs typeface="Be Vietnam Pro" pitchFamily="34" charset="-120"/>
-              </a:rPr>
-              <a:t> khi</a:t>
-            </a:r>
-            <a:r>
-              <a:rPr lang="en-US" sz="2400" dirty="0" spc="-6" kern="0">
-                <a:solidFill>
-                  <a:srgbClr val="E4E1D8"/>
-                </a:solidFill>
-                <a:latin typeface="Be Vietnam Pro" pitchFamily="34" charset="0"/>
-                <a:ea typeface="Be Vietnam Pro" pitchFamily="34" charset="-122"/>
-                <a:cs typeface="Be Vietnam Pro" pitchFamily="34" charset="-120"/>
-              </a:rPr>
-              <a:t> máy</a:t>
-            </a:r>
-            <a:r>
-              <a:rPr lang="en-US" sz="2400" dirty="0" spc="1" kern="0">
-                <a:solidFill>
-                  <a:srgbClr val="E4E1D8"/>
-                </a:solidFill>
-                <a:latin typeface="Be Vietnam Pro" pitchFamily="34" charset="0"/>
-                <a:ea typeface="Be Vietnam Pro" pitchFamily="34" charset="-122"/>
-                <a:cs typeface="Be Vietnam Pro" pitchFamily="34" charset="-120"/>
-              </a:rPr>
-              <a:t> hỏng:</a:t>
-            </a:r>
-            <a:r>
-              <a:rPr lang="en-US" sz="2400" dirty="0" spc="-7" kern="0">
-                <a:solidFill>
-                  <a:srgbClr val="E4E1D8"/>
-                </a:solidFill>
-                <a:latin typeface="Be Vietnam Pro" pitchFamily="34" charset="0"/>
-                <a:ea typeface="Be Vietnam Pro" pitchFamily="34" charset="-122"/>
-                <a:cs typeface="Be Vietnam Pro" pitchFamily="34" charset="-120"/>
-              </a:rPr>
-              <a:t> nhật</a:t>
-            </a:r>
-            <a:r>
-              <a:rPr lang="en-US" sz="2400" dirty="0" spc="-1" kern="0">
-                <a:solidFill>
-                  <a:srgbClr val="E4E1D8"/>
-                </a:solidFill>
-                <a:latin typeface="Be Vietnam Pro" pitchFamily="34" charset="0"/>
-                <a:ea typeface="Be Vietnam Pro" pitchFamily="34" charset="-122"/>
-                <a:cs typeface="Be Vietnam Pro" pitchFamily="34" charset="-120"/>
-              </a:rPr>
-              <a:t> ký, bản</a:t>
-            </a:r>
-            <a:r>
-              <a:rPr lang="en-US" sz="2400" dirty="0" spc="-5" kern="0">
-                <a:solidFill>
-                  <a:srgbClr val="E4E1D8"/>
-                </a:solidFill>
-                <a:latin typeface="Be Vietnam Pro" pitchFamily="34" charset="0"/>
-                <a:ea typeface="Be Vietnam Pro" pitchFamily="34" charset="-122"/>
-                <a:cs typeface="Be Vietnam Pro" pitchFamily="34" charset="-120"/>
-              </a:rPr>
-              <a:t> sao</a:t>
-            </a:r>
-            <a:r>
-              <a:rPr lang="en-US" sz="2400" dirty="0" spc="2" kern="0">
-                <a:solidFill>
-                  <a:srgbClr val="E4E1D8"/>
-                </a:solidFill>
-                <a:latin typeface="Be Vietnam Pro" pitchFamily="34" charset="0"/>
-                <a:ea typeface="Be Vietnam Pro" pitchFamily="34" charset="-122"/>
-                <a:cs typeface="Be Vietnam Pro" pitchFamily="34" charset="-120"/>
-              </a:rPr>
-              <a:t> ở</a:t>
-            </a:r>
-            <a:r>
-              <a:rPr lang="en-US" sz="2400" dirty="0" spc="-6" kern="0">
-                <a:solidFill>
-                  <a:srgbClr val="E4E1D8"/>
-                </a:solidFill>
-                <a:latin typeface="Be Vietnam Pro" pitchFamily="34" charset="0"/>
-                <a:ea typeface="Be Vietnam Pro" pitchFamily="34" charset="-122"/>
-                <a:cs typeface="Be Vietnam Pro" pitchFamily="34" charset="-120"/>
-              </a:rPr>
-              <a:t> máy</a:t>
-            </a:r>
-            <a:r>
-              <a:rPr lang="en-US" sz="2400" dirty="0" spc="-1" kern="0">
-                <a:solidFill>
-                  <a:srgbClr val="E4E1D8"/>
-                </a:solidFill>
-                <a:latin typeface="Be Vietnam Pro" pitchFamily="34" charset="0"/>
-                <a:ea typeface="Be Vietnam Pro" pitchFamily="34" charset="-122"/>
-                <a:cs typeface="Be Vietnam Pro" pitchFamily="34" charset="-120"/>
-              </a:rPr>
-              <a:t> khác.</a:t>
-            </a:r>
-            <a:r>
-              <a:rPr lang="en-US" sz="2400" dirty="0" spc="-17" kern="0">
-                <a:solidFill>
-                  <a:srgbClr val="E4E1D8"/>
-                </a:solidFill>
-                <a:latin typeface="Be Vietnam Pro" pitchFamily="34" charset="0"/>
-                <a:ea typeface="Be Vietnam Pro" pitchFamily="34" charset="-122"/>
-                <a:cs typeface="Be Vietnam Pro" pitchFamily="34" charset="-120"/>
-              </a:rPr>
-              <a:t> “Làm</a:t>
-            </a:r>
-            <a:r>
-              <a:rPr lang="en-US" sz="2400" dirty="0" spc="-5" kern="0">
-                <a:solidFill>
-                  <a:srgbClr val="E4E1D8"/>
-                </a:solidFill>
-                <a:latin typeface="Be Vietnam Pro" pitchFamily="34" charset="0"/>
-                <a:ea typeface="Be Vietnam Pro" pitchFamily="34" charset="-122"/>
-                <a:cs typeface="Be Vietnam Pro" pitchFamily="34" charset="-120"/>
-              </a:rPr>
-              <a:t> sau”</a:t>
-            </a:r>
-            <a:r>
-              <a:rPr lang="en-US" sz="2400" dirty="0" spc="1" kern="0">
-                <a:solidFill>
-                  <a:srgbClr val="E4E1D8"/>
-                </a:solidFill>
-                <a:latin typeface="Be Vietnam Pro" pitchFamily="34" charset="0"/>
-                <a:ea typeface="Be Vietnam Pro" pitchFamily="34" charset="-122"/>
-                <a:cs typeface="Be Vietnam Pro" pitchFamily="34" charset="-120"/>
-              </a:rPr>
-              <a:t> không</a:t>
-            </a:r>
-            <a:r>
-              <a:rPr lang="en-US" sz="2400" dirty="0" spc="0" kern="0">
-                <a:solidFill>
-                  <a:srgbClr val="E4E1D8"/>
-                </a:solidFill>
-                <a:latin typeface="Be Vietnam Pro" pitchFamily="34" charset="0"/>
-                <a:ea typeface="Be Vietnam Pro" pitchFamily="34" charset="-122"/>
-                <a:cs typeface="Be Vietnam Pro" pitchFamily="34" charset="-120"/>
-              </a:rPr>
-              <a:t> phải</a:t>
-            </a:r>
-            <a:r>
-              <a:rPr lang="en-US" sz="2400" dirty="0" spc="1" kern="0">
-                <a:solidFill>
-                  <a:srgbClr val="E4E1D8"/>
-                </a:solidFill>
-                <a:latin typeface="Be Vietnam Pro" pitchFamily="34" charset="0"/>
-                <a:ea typeface="Be Vietnam Pro" pitchFamily="34" charset="-122"/>
-                <a:cs typeface="Be Vietnam Pro" pitchFamily="34" charset="-120"/>
-              </a:rPr>
-              <a:t> “không</a:t>
-            </a:r>
-            <a:r>
-              <a:rPr lang="en-US" sz="2400" dirty="0" spc="0" kern="0">
-                <a:solidFill>
-                  <a:srgbClr val="E4E1D8"/>
-                </a:solidFill>
-                <a:latin typeface="Be Vietnam Pro" pitchFamily="34" charset="0"/>
-                <a:ea typeface="Be Vietnam Pro" pitchFamily="34" charset="-122"/>
-                <a:cs typeface="Be Vietnam Pro" pitchFamily="34" charset="-120"/>
-              </a:rPr>
-              <a:t> cần”.</a:t>
+              <a:t> lệnh.</a:t>
             </a:r>
             <a:endParaRPr lang="en-US" sz="2400" dirty="0"/>
           </a:p>
@@ -14331,7 +13789,7 @@
               <a:buNone/>
             </a:pPr>
             <a:r>
-              <a:rPr lang="en-US" sz="2400" dirty="0" spc="1" kern="0">
+              <a:rPr lang="en-US" sz="2400" dirty="0" spc="-1" kern="0">
                 <a:solidFill>
                   <a:srgbClr val="E4E1D8"/>
                 </a:solidFill>
@@ -14339,10 +13797,10 @@
                 <a:ea typeface="Be Vietnam Pro" pitchFamily="34" charset="-122"/>
                 <a:cs typeface="Be Vietnam Pro" pitchFamily="34" charset="-120"/>
               </a:rPr>
-              <a:t>So</a:t>
-            </a:r>
-            <a:r>
-              <a:rPr lang="en-US" sz="2400" dirty="0" spc="-5" kern="0">
+              <a:t>Chỉ</a:t>
+            </a:r>
+            <a:r>
+              <a:rPr lang="en-US" sz="2400" dirty="0" spc="12" kern="0">
                 <a:solidFill>
                   <a:srgbClr val="E4E1D8"/>
                 </a:solidFill>
@@ -14350,10 +13808,10 @@
                 <a:ea typeface="Be Vietnam Pro" pitchFamily="34" charset="-122"/>
                 <a:cs typeface="Be Vietnam Pro" pitchFamily="34" charset="-120"/>
               </a:rPr>
-              <a:t> sánh</a:t>
-            </a:r>
-            <a:r>
-              <a:rPr lang="en-US" sz="2400" dirty="0" spc="-23" kern="0">
+              <a:t> đổi</a:t>
+            </a:r>
+            <a:r>
+              <a:rPr lang="en-US" sz="2400" dirty="0" spc="2" kern="0">
                 <a:solidFill>
                   <a:srgbClr val="E4E1D8"/>
                 </a:solidFill>
@@ -14361,10 +13819,10 @@
                 <a:ea typeface="Be Vietnam Pro" pitchFamily="34" charset="-122"/>
                 <a:cs typeface="Be Vietnam Pro" pitchFamily="34" charset="-120"/>
               </a:rPr>
-              <a:t> rồi</a:t>
-            </a:r>
-            <a:r>
-              <a:rPr lang="en-US" sz="2400" dirty="0" spc="0" kern="0">
+              <a:t> giá</a:t>
+            </a:r>
+            <a:r>
+              <a:rPr lang="en-US" sz="2400" dirty="0" spc="14" kern="0">
                 <a:solidFill>
                   <a:srgbClr val="E4E1D8"/>
                 </a:solidFill>
@@ -14372,62 +13830,7 @@
                 <a:ea typeface="Be Vietnam Pro" pitchFamily="34" charset="-122"/>
                 <a:cs typeface="Be Vietnam Pro" pitchFamily="34" charset="-120"/>
               </a:rPr>
-              <a:t> hoán</a:t>
-            </a:r>
-            <a:r>
-              <a:rPr lang="en-US" sz="2400" dirty="0" spc="9" kern="0">
-                <a:solidFill>
-                  <a:srgbClr val="E4E1D8"/>
-                </a:solidFill>
-                <a:latin typeface="Be Vietnam Pro" pitchFamily="34" charset="0"/>
-                <a:ea typeface="Be Vietnam Pro" pitchFamily="34" charset="-122"/>
-                <a:cs typeface="Be Vietnam Pro" pitchFamily="34" charset="-120"/>
-              </a:rPr>
-              <a:t> đổi:</a:t>
-            </a:r>
-            <a:r>
-              <a:rPr lang="en-US" sz="2400" dirty="0" spc="13" kern="0">
-                <a:solidFill>
-                  <a:srgbClr val="E4E1D8"/>
-                </a:solidFill>
-                <a:latin typeface="Be Vietnam Pro" pitchFamily="34" charset="0"/>
-                <a:ea typeface="Be Vietnam Pro" pitchFamily="34" charset="-122"/>
-                <a:cs typeface="Be Vietnam Pro" pitchFamily="34" charset="-120"/>
-              </a:rPr>
-              <a:t> đổi</a:t>
-            </a:r>
-            <a:r>
-              <a:rPr lang="en-US" sz="2400" dirty="0" spc="2" kern="0">
-                <a:solidFill>
-                  <a:srgbClr val="E4E1D8"/>
-                </a:solidFill>
-                <a:latin typeface="Be Vietnam Pro" pitchFamily="34" charset="0"/>
-                <a:ea typeface="Be Vietnam Pro" pitchFamily="34" charset="-122"/>
-                <a:cs typeface="Be Vietnam Pro" pitchFamily="34" charset="-120"/>
-              </a:rPr>
-              <a:t> giá</a:t>
-            </a:r>
-            <a:r>
-              <a:rPr lang="en-US" sz="2400" dirty="0" spc="14" kern="0">
-                <a:solidFill>
-                  <a:srgbClr val="E4E1D8"/>
-                </a:solidFill>
-                <a:latin typeface="Be Vietnam Pro" pitchFamily="34" charset="0"/>
-                <a:ea typeface="Be Vietnam Pro" pitchFamily="34" charset="-122"/>
-                <a:cs typeface="Be Vietnam Pro" pitchFamily="34" charset="-120"/>
-              </a:rPr>
               <a:t> trị</a:t>
-            </a:r>
-            <a:r>
-              <a:rPr lang="en-US" sz="2400" dirty="0" spc="-1" kern="0">
-                <a:solidFill>
-                  <a:srgbClr val="E4E1D8"/>
-                </a:solidFill>
-                <a:latin typeface="Be Vietnam Pro" pitchFamily="34" charset="0"/>
-                <a:ea typeface="Be Vietnam Pro" pitchFamily="34" charset="-122"/>
-                <a:cs typeface="Be Vietnam Pro" pitchFamily="34" charset="-120"/>
-              </a:rPr>
-              <a:t> chỉ</a:t>
             </a:r>
             <a:r>
               <a:rPr lang="en-US" sz="2400" dirty="0" spc="-2" kern="0">
@@ -14713,17 +14116,17 @@
           <a:ln/>
         </p:spPr>
         <p:txBody>
-          <a:bodyPr wrap="square" lIns="0" tIns="4004" rIns="0" bIns="-4004" rtlCol="0" anchor="t"/>
+          <a:bodyPr wrap="square" lIns="0" tIns="4001" rIns="0" bIns="-4001" rtlCol="0" anchor="t"/>
           <a:lstStyle/>
           <a:p>
             <a:pPr algn="l" indent="0" marL="0">
               <a:lnSpc>
-                <a:spcPts val="2514"/>
+                <a:spcPts val="2520"/>
               </a:lnSpc>
               <a:buNone/>
             </a:pPr>
             <a:r>
-              <a:rPr lang="en-US" sz="1796" dirty="0" spc="-3" kern="0">
+              <a:rPr lang="en-US" sz="1800" dirty="0" spc="-3" kern="0">
                 <a:solidFill>
                   <a:srgbClr val="9AA0B5"/>
                 </a:solidFill>
@@ -14731,10 +14134,10 @@
                 <a:ea typeface="Be Vietnam Pro" pitchFamily="34" charset="-122"/>
                 <a:cs typeface="Be Vietnam Pro" pitchFamily="34" charset="-120"/>
               </a:rPr>
-              <a:t>Mỗi</a:t>
-            </a:r>
-            <a:r>
-              <a:rPr lang="en-US" sz="1796" dirty="0" spc="2" kern="0">
+              <a:t>Nguồn</a:t>
+            </a:r>
+            <a:r>
+              <a:rPr lang="en-US" sz="1800" dirty="0" spc="-9" kern="0">
                 <a:solidFill>
                   <a:srgbClr val="9AA0B5"/>
                 </a:solidFill>
@@ -14742,10 +14145,10 @@
                 <a:ea typeface="Be Vietnam Pro" pitchFamily="34" charset="-122"/>
                 <a:cs typeface="Be Vietnam Pro" pitchFamily="34" charset="-120"/>
               </a:rPr>
-              <a:t> nguồn</a:t>
-            </a:r>
-            <a:r>
-              <a:rPr lang="en-US" sz="1796" dirty="0" spc="-8" kern="0">
+              <a:t> tại</a:t>
+            </a:r>
+            <a:r>
+              <a:rPr lang="en-US" sz="1800" dirty="0" spc="-1" kern="0">
                 <a:solidFill>
                   <a:srgbClr val="9AA0B5"/>
                 </a:solidFill>
@@ -14753,10 +14156,10 @@
                 <a:ea typeface="Be Vietnam Pro" pitchFamily="34" charset="-122"/>
                 <a:cs typeface="Be Vietnam Pro" pitchFamily="34" charset="-120"/>
               </a:rPr>
-              <a:t> tại</a:t>
-            </a:r>
-            <a:r>
-              <a:rPr lang="en-US" sz="1796" dirty="0" spc="-3" kern="0">
+              <a:t> commit</a:t>
+            </a:r>
+            <a:r>
+              <a:rPr lang="en-US" sz="1800" dirty="0" spc="2" kern="0">
                 <a:solidFill>
                   <a:srgbClr val="9AA0B5"/>
                 </a:solidFill>
@@ -14764,10 +14167,10 @@
                 <a:ea typeface="Be Vietnam Pro" pitchFamily="34" charset="-122"/>
                 <a:cs typeface="Be Vietnam Pro" pitchFamily="34" charset="-120"/>
               </a:rPr>
-              <a:t> một</a:t>
-            </a:r>
-            <a:r>
-              <a:rPr lang="en-US" sz="1796" dirty="0" spc="3" kern="0">
+              <a:t> cố</a:t>
+            </a:r>
+            <a:r>
+              <a:rPr lang="en-US" sz="1800" dirty="0" spc="10" kern="0">
                 <a:solidFill>
                   <a:srgbClr val="9AA0B5"/>
                 </a:solidFill>
@@ -14775,10 +14178,10 @@
                 <a:ea typeface="Be Vietnam Pro" pitchFamily="34" charset="-122"/>
                 <a:cs typeface="Be Vietnam Pro" pitchFamily="34" charset="-120"/>
               </a:rPr>
-              <a:t> commit</a:t>
-            </a:r>
-            <a:r>
-              <a:rPr lang="en-US" sz="1796" dirty="0" spc="-2" kern="0">
+              <a:t> định;</a:t>
+            </a:r>
+            <a:r>
+              <a:rPr lang="en-US" sz="1800" dirty="0" spc="16" kern="0">
                 <a:solidFill>
                   <a:srgbClr val="9AA0B5"/>
                 </a:solidFill>
@@ -14786,10 +14189,10 @@
                 <a:ea typeface="Be Vietnam Pro" pitchFamily="34" charset="-122"/>
                 <a:cs typeface="Be Vietnam Pro" pitchFamily="34" charset="-120"/>
               </a:rPr>
-              <a:t> cố</a:t>
-            </a:r>
-            <a:r>
-              <a:rPr lang="en-US" sz="1796" dirty="0" spc="12" kern="0">
+              <a:t> đo</a:t>
+            </a:r>
+            <a:r>
+              <a:rPr lang="en-US" sz="1800" dirty="0" spc="-14" kern="0">
                 <a:solidFill>
                   <a:srgbClr val="9AA0B5"/>
                 </a:solidFill>
@@ -14797,10 +14200,10 @@
                 <a:ea typeface="Be Vietnam Pro" pitchFamily="34" charset="-122"/>
                 <a:cs typeface="Be Vietnam Pro" pitchFamily="34" charset="-120"/>
               </a:rPr>
-              <a:t> định.</a:t>
-            </a:r>
-            <a:r>
-              <a:rPr lang="en-US" sz="1796" dirty="0" spc="2" kern="0">
+              <a:t> ngày</a:t>
+            </a:r>
+            <a:r>
+              <a:rPr lang="en-US" sz="1800" dirty="0" spc="1" kern="0">
                 <a:solidFill>
                   <a:srgbClr val="9AA0B5"/>
                 </a:solidFill>
@@ -14808,75 +14211,9 @@
                 <a:ea typeface="Be Vietnam Pro" pitchFamily="34" charset="-122"/>
                 <a:cs typeface="Be Vietnam Pro" pitchFamily="34" charset="-120"/>
               </a:rPr>
-              <a:t> Đo</a:t>
-            </a:r>
-            <a:r>
-              <a:rPr lang="en-US" sz="1796" dirty="0" spc="-11" kern="0">
-                <a:solidFill>
-                  <a:srgbClr val="9AA0B5"/>
-                </a:solidFill>
-                <a:latin typeface="Be Vietnam Pro" pitchFamily="34" charset="0"/>
-                <a:ea typeface="Be Vietnam Pro" pitchFamily="34" charset="-122"/>
-                <a:cs typeface="Be Vietnam Pro" pitchFamily="34" charset="-120"/>
-              </a:rPr>
-              <a:t> ngày</a:t>
-            </a:r>
-            <a:r>
-              <a:rPr lang="en-US" sz="1796" dirty="0" spc="0" kern="0">
-                <a:solidFill>
-                  <a:srgbClr val="9AA0B5"/>
-                </a:solidFill>
-                <a:latin typeface="Be Vietnam Pro" pitchFamily="34" charset="0"/>
-                <a:ea typeface="Be Vietnam Pro" pitchFamily="34" charset="-122"/>
-                <a:cs typeface="Be Vietnam Pro" pitchFamily="34" charset="-120"/>
-              </a:rPr>
-              <a:t> 2026-10-18. Hình</a:t>
-            </a:r>
-            <a:r>
-              <a:rPr lang="en-US" sz="1796" dirty="0" spc="-2" kern="0">
-                <a:solidFill>
-                  <a:srgbClr val="9AA0B5"/>
-                </a:solidFill>
-                <a:latin typeface="Be Vietnam Pro" pitchFamily="34" charset="0"/>
-                <a:ea typeface="Be Vietnam Pro" pitchFamily="34" charset="-122"/>
-                <a:cs typeface="Be Vietnam Pro" pitchFamily="34" charset="-120"/>
-              </a:rPr>
-              <a:t> thiết</a:t>
-            </a:r>
-            <a:r>
-              <a:rPr lang="en-US" sz="1796" dirty="0" spc="-31" kern="0">
-                <a:solidFill>
-                  <a:srgbClr val="9AA0B5"/>
-                </a:solidFill>
-                <a:latin typeface="Be Vietnam Pro" pitchFamily="34" charset="0"/>
-                <a:ea typeface="Be Vietnam Pro" pitchFamily="34" charset="-122"/>
-                <a:cs typeface="Be Vietnam Pro" pitchFamily="34" charset="-120"/>
-              </a:rPr>
-              <a:t> kế</a:t>
-            </a:r>
-            <a:r>
-              <a:rPr lang="en-US" sz="1796" dirty="0" spc="7" kern="0">
-                <a:solidFill>
-                  <a:srgbClr val="9AA0B5"/>
-                </a:solidFill>
-                <a:latin typeface="Be Vietnam Pro" pitchFamily="34" charset="0"/>
-                <a:ea typeface="Be Vietnam Pro" pitchFamily="34" charset="-122"/>
-                <a:cs typeface="Be Vietnam Pro" pitchFamily="34" charset="-120"/>
-              </a:rPr>
-              <a:t> độc</a:t>
-            </a:r>
-            <a:r>
-              <a:rPr lang="en-US" sz="1796" dirty="0" spc="-2" kern="0">
-                <a:solidFill>
-                  <a:srgbClr val="9AA0B5"/>
-                </a:solidFill>
-                <a:latin typeface="Be Vietnam Pro" pitchFamily="34" charset="0"/>
-                <a:ea typeface="Be Vietnam Pro" pitchFamily="34" charset="-122"/>
-                <a:cs typeface="Be Vietnam Pro" pitchFamily="34" charset="-120"/>
-              </a:rPr>
-              <a:t> lập.</a:t>
-            </a:r>
-            <a:endParaRPr lang="en-US" sz="1796" dirty="0"/>
+              <a:t> 2026-10-18.</a:t>
+            </a:r>
+            <a:endParaRPr lang="en-US" sz="1800" dirty="0"/>
           </a:p>
         </p:txBody>
       </p:sp>

</xml_diff>